<commit_message>
Module 9: live project is now GitHub setup, key, one build prompt and the routine; FinBERT also misreads the crude headline
Co-Authored-By: Claude Opus 5.5 <noreply@anthropic.com>
</commit_message>
<xml_diff>
--- a/slides/Module-09-Market-Commentary-and-Dashboards.pptx
+++ b/slides/Module-09-Market-Commentary-and-Dashboards.pptx
@@ -4393,7 +4393,7 @@
                   <a:srgbClr val="1B2A41"/>
                 </a:solidFill>
               </a:rPr>
-              <a:t>Why can a word list get sentiment wrong?</a:t>
+              <a:t>Why can even FinBERT get a headline wrong?</a:t>
             </a:r>
           </a:p>
           <a:p>
@@ -4416,7 +4416,7 @@
                   <a:srgbClr val="5D6B7E"/>
                 </a:solidFill>
               </a:rPr>
-              <a:t>It ignores context. Falling crude is good for India, but the word list may call it negative.</a:t>
+              <a:t>It scores the tone of the words, not who benefits. Falling crude helps India, yet it scores negative.</a:t>
             </a:r>
           </a:p>
         </p:txBody>
@@ -5951,7 +5951,7 @@
                   <a:srgbClr val="3A5C9E"/>
                 </a:solidFill>
               </a:rPr>
-              <a:t>WHY NOT A WORD LIST?</a:t>
+              <a:t>THE TRAP</a:t>
             </a:r>
           </a:p>
           <a:p>
@@ -5967,7 +5967,7 @@
                 </a:solidFill>
                 <a:latin typeface="Georgia"/>
               </a:rPr>
-              <a:t>Words mislead</a:t>
+              <a:t>Tone is not impact</a:t>
             </a:r>
           </a:p>
           <a:p>
@@ -5982,7 +5982,7 @@
                   <a:srgbClr val="1B2A41"/>
                 </a:solidFill>
               </a:rPr>
-              <a:t>“Crude oil falls as supply concerns ease” is good news for India. A word list sees “concerns” and calls it negative.</a:t>
+              <a:t>“Crude oil falls as supply concerns ease” is good news for India. A word list and FinBERT both call it negative.</a:t>
             </a:r>
           </a:p>
         </p:txBody>
@@ -6571,7 +6571,7 @@
                   <a:srgbClr val="FFFFFF"/>
                 </a:solidFill>
               </a:rPr>
-              <a:t>sentiment is a signal, not a decision. It tells you the mood, not what to buy.</a:t>
+              <a:t>sentiment scores the tone of the words. Who benefits needs context from a person or an LLM, and it is never a decision to buy.</a:t>
             </a:r>
           </a:p>
         </p:txBody>
@@ -13006,7 +13006,7 @@
                   <a:srgbClr val="C9A227"/>
                 </a:solidFill>
               </a:rPr>
-              <a:t>HOUR 3 · THE LIVE LAB</a:t>
+              <a:t>HOUR 3 · THE LIVE PROJECT</a:t>
             </a:r>
           </a:p>
         </p:txBody>
@@ -13041,7 +13041,7 @@
                 </a:solidFill>
                 <a:latin typeface="Georgia"/>
               </a:rPr>
-              <a:t>Build your own pre-market dashboard</a:t>
+              <a:t>Build a dashboard that updates itself every morning</a:t>
             </a:r>
           </a:p>
         </p:txBody>
@@ -13163,7 +13163,7 @@
                   <a:srgbClr val="3A5C9E"/>
                 </a:solidFill>
               </a:rPr>
-              <a:t>PART A · 20 MIN</a:t>
+              <a:t>STEP 1 · 15 MIN</a:t>
             </a:r>
           </a:p>
           <a:p>
@@ -13179,7 +13179,7 @@
                 </a:solidFill>
                 <a:latin typeface="Georgia"/>
               </a:rPr>
-              <a:t>Watch it live</a:t>
+              <a:t>Set up GitHub</a:t>
             </a:r>
           </a:p>
           <a:p>
@@ -13194,7 +13194,7 @@
                   <a:srgbClr val="1B2A41"/>
                 </a:solidFill>
               </a:rPr>
-              <a:t>The instructor opens the daily market dashboard and runs its job by hand.</a:t>
+              <a:t>Create a public repository, add your API key as a secret, and turn on GitHub Pages.</a:t>
             </a:r>
           </a:p>
         </p:txBody>
@@ -13316,7 +13316,7 @@
                   <a:srgbClr val="3A5C9E"/>
                 </a:solidFill>
               </a:rPr>
-              <a:t>PART B · 40 MIN</a:t>
+              <a:t>STEP 2 · 20 MIN</a:t>
             </a:r>
           </a:p>
           <a:p>
@@ -13332,7 +13332,7 @@
                 </a:solidFill>
                 <a:latin typeface="Georgia"/>
               </a:rPr>
-              <a:t>Build your version</a:t>
+              <a:t>Paste one prompt</a:t>
             </a:r>
           </a:p>
           <a:p>
@@ -13347,7 +13347,7 @@
                   <a:srgbClr val="1B2A41"/>
                 </a:solidFill>
               </a:rPr>
-              <a:t>Run build_dashboard.py. Python computes the gap, flows, VIX, news mood and a DCF, then writes dashboard.html.</a:t>
+              <a:t>Open the repository in Claude Code and paste the build prompt from the lab page. It writes every file.</a:t>
             </a:r>
           </a:p>
         </p:txBody>
@@ -13469,7 +13469,7 @@
                   <a:srgbClr val="C9A227"/>
                 </a:solidFill>
               </a:rPr>
-              <a:t>PART C · 30 MIN</a:t>
+              <a:t>STEP 3 · 15 MIN</a:t>
             </a:r>
           </a:p>
           <a:p>
@@ -13485,7 +13485,7 @@
                 </a:solidFill>
                 <a:latin typeface="Georgia"/>
               </a:rPr>
-              <a:t>Write and check the brief</a:t>
+              <a:t>Set the routine and run it</a:t>
             </a:r>
           </a:p>
           <a:p>
@@ -13500,7 +13500,7 @@
                   <a:srgbClr val="C9D6EE"/>
                 </a:solidFill>
               </a:rPr>
-              <a:t>Paste the printed prompt into any free AI chat. Check every number. Swap with the next desk.</a:t>
+              <a:t>The schedule runs it at 6:30 AM on weekdays. Press Run workflow once to test it now.</a:t>
             </a:r>
           </a:p>
         </p:txBody>
@@ -13622,7 +13622,7 @@
                   <a:srgbClr val="C9A227"/>
                 </a:solidFill>
               </a:rPr>
-              <a:t>Free and keyless:  </a:t>
+              <a:t>No API key?  </a:t>
             </a:r>
             <a:r>
               <a:rPr sz="1200" b="0">
@@ -13630,7 +13630,7 @@
                   <a:srgbClr val="FFFFFF"/>
                 </a:solidFill>
               </a:rPr>
-              <a:t>built-in Python only. The snapshot is illustrative. Run it with --break to watch it refuse a missing number.</a:t>
+              <a:t>the lab page also has a free practice version in plain Python, with a DCF and a refusal on missing data.</a:t>
             </a:r>
           </a:p>
         </p:txBody>

</xml_diff>

<commit_message>
Module 9 live lab: four steps (GitHub, API key, connect Claude, prompt)
Co-Authored-By: Claude Opus 5.5 <noreply@anthropic.com>
</commit_message>
<xml_diff>
--- a/slides/Module-09-Market-Commentary-and-Dashboards.pptx
+++ b/slides/Module-09-Market-Commentary-and-Dashboards.pptx
@@ -13055,7 +13055,7 @@
         <p:spPr>
           <a:xfrm>
             <a:off x="548640" y="1463040"/>
-            <a:ext cx="3593592" cy="4160520"/>
+            <a:ext cx="2656332" cy="4160520"/>
           </a:xfrm>
           <a:prstGeom prst="rect">
             <a:avLst/>
@@ -13099,7 +13099,7 @@
         <p:spPr>
           <a:xfrm>
             <a:off x="548640" y="1463040"/>
-            <a:ext cx="3593592" cy="45720"/>
+            <a:ext cx="2656332" cy="45720"/>
           </a:xfrm>
           <a:prstGeom prst="rect">
             <a:avLst/>
@@ -13143,7 +13143,7 @@
         <p:spPr>
           <a:xfrm>
             <a:off x="804672" y="1664208"/>
-            <a:ext cx="3081528" cy="3886200"/>
+            <a:ext cx="2144268" cy="3886200"/>
           </a:xfrm>
           <a:prstGeom prst="rect">
             <a:avLst/>
@@ -13163,7 +13163,7 @@
                   <a:srgbClr val="3A5C9E"/>
                 </a:solidFill>
               </a:rPr>
-              <a:t>STEP 1 · 15 MIN</a:t>
+              <a:t>STEP 1</a:t>
             </a:r>
           </a:p>
           <a:p>
@@ -13179,7 +13179,7 @@
                 </a:solidFill>
                 <a:latin typeface="Georgia"/>
               </a:rPr>
-              <a:t>Set up GitHub</a:t>
+              <a:t>GitHub setup</a:t>
             </a:r>
           </a:p>
           <a:p>
@@ -13194,7 +13194,7 @@
                   <a:srgbClr val="1B2A41"/>
                 </a:solidFill>
               </a:rPr>
-              <a:t>Create a public repository, add your API key as a secret, and turn on GitHub Pages.</a:t>
+              <a:t>Create a public repository and turn on Actions write access and Pages.</a:t>
             </a:r>
           </a:p>
         </p:txBody>
@@ -13207,8 +13207,8 @@
         </p:nvSpPr>
         <p:spPr>
           <a:xfrm>
-            <a:off x="4297680" y="1463040"/>
-            <a:ext cx="3593592" cy="4160520"/>
+            <a:off x="3360420" y="1463040"/>
+            <a:ext cx="2656332" cy="4160520"/>
           </a:xfrm>
           <a:prstGeom prst="rect">
             <a:avLst/>
@@ -13251,8 +13251,8 @@
         </p:nvSpPr>
         <p:spPr>
           <a:xfrm>
-            <a:off x="4297680" y="1463040"/>
-            <a:ext cx="3593592" cy="45720"/>
+            <a:off x="3360420" y="1463040"/>
+            <a:ext cx="2656332" cy="45720"/>
           </a:xfrm>
           <a:prstGeom prst="rect">
             <a:avLst/>
@@ -13295,8 +13295,8 @@
         </p:nvSpPr>
         <p:spPr>
           <a:xfrm>
-            <a:off x="4553712" y="1664208"/>
-            <a:ext cx="3081528" cy="3886200"/>
+            <a:off x="3616452" y="1664208"/>
+            <a:ext cx="2144268" cy="3886200"/>
           </a:xfrm>
           <a:prstGeom prst="rect">
             <a:avLst/>
@@ -13316,7 +13316,7 @@
                   <a:srgbClr val="3A5C9E"/>
                 </a:solidFill>
               </a:rPr>
-              <a:t>STEP 2 · 20 MIN</a:t>
+              <a:t>STEP 2</a:t>
             </a:r>
           </a:p>
           <a:p>
@@ -13332,7 +13332,7 @@
                 </a:solidFill>
                 <a:latin typeface="Georgia"/>
               </a:rPr>
-              <a:t>Paste one prompt</a:t>
+              <a:t>API key</a:t>
             </a:r>
           </a:p>
           <a:p>
@@ -13347,7 +13347,7 @@
                   <a:srgbClr val="1B2A41"/>
                 </a:solidFill>
               </a:rPr>
-              <a:t>Open the repository in Claude Code and paste the build prompt from the lab page. It writes every file.</a:t>
+              <a:t>Create a key at console.anthropic.com and save it as a repository secret.</a:t>
             </a:r>
           </a:p>
         </p:txBody>
@@ -13360,14 +13360,14 @@
         </p:nvSpPr>
         <p:spPr>
           <a:xfrm>
-            <a:off x="8046720" y="1463040"/>
-            <a:ext cx="3593592" cy="4160520"/>
-          </a:xfrm>
-          <a:prstGeom prst="rect">
-            <a:avLst/>
-          </a:prstGeom>
-          <a:solidFill>
-            <a:srgbClr val="0F2145"/>
+            <a:off x="6172200" y="1463040"/>
+            <a:ext cx="2656332" cy="4160520"/>
+          </a:xfrm>
+          <a:prstGeom prst="rect">
+            <a:avLst/>
+          </a:prstGeom>
+          <a:solidFill>
+            <a:srgbClr val="FFFFFF"/>
           </a:solidFill>
           <a:ln>
             <a:noFill/>
@@ -13404,8 +13404,8 @@
         </p:nvSpPr>
         <p:spPr>
           <a:xfrm>
-            <a:off x="8046720" y="1463040"/>
-            <a:ext cx="3593592" cy="45720"/>
+            <a:off x="6172200" y="1463040"/>
+            <a:ext cx="2656332" cy="45720"/>
           </a:xfrm>
           <a:prstGeom prst="rect">
             <a:avLst/>
@@ -13448,8 +13448,8 @@
         </p:nvSpPr>
         <p:spPr>
           <a:xfrm>
-            <a:off x="8302752" y="1664208"/>
-            <a:ext cx="3081528" cy="3886200"/>
+            <a:off x="6428232" y="1664208"/>
+            <a:ext cx="2144268" cy="3886200"/>
           </a:xfrm>
           <a:prstGeom prst="rect">
             <a:avLst/>
@@ -13466,10 +13466,10 @@
             <a:r>
               <a:rPr sz="1000" b="1">
                 <a:solidFill>
-                  <a:srgbClr val="C9A227"/>
-                </a:solidFill>
-              </a:rPr>
-              <a:t>STEP 3 · 15 MIN</a:t>
+                  <a:srgbClr val="3A5C9E"/>
+                </a:solidFill>
+              </a:rPr>
+              <a:t>STEP 3</a:t>
             </a:r>
           </a:p>
           <a:p>
@@ -13481,11 +13481,11 @@
             <a:r>
               <a:rPr sz="1600" b="1">
                 <a:solidFill>
-                  <a:srgbClr val="FFFFFF"/>
+                  <a:srgbClr val="0F2145"/>
                 </a:solidFill>
                 <a:latin typeface="Georgia"/>
               </a:rPr>
-              <a:t>Set the routine and run it</a:t>
+              <a:t>Connect Claude</a:t>
             </a:r>
           </a:p>
           <a:p>
@@ -13497,10 +13497,10 @@
             <a:r>
               <a:rPr sz="1200" b="0">
                 <a:solidFill>
-                  <a:srgbClr val="C9D6EE"/>
-                </a:solidFill>
-              </a:rPr>
-              <a:t>The schedule runs it at 6:30 AM on weekdays. Press Run workflow once to test it now.</a:t>
+                  <a:srgbClr val="1B2A41"/>
+                </a:solidFill>
+              </a:rPr>
+              <a:t>At claude.ai/code, connect GitHub and allow the Claude app on the repository.</a:t>
             </a:r>
           </a:p>
         </p:txBody>
@@ -13513,8 +13513,8 @@
         </p:nvSpPr>
         <p:spPr>
           <a:xfrm>
-            <a:off x="548640" y="5760720"/>
-            <a:ext cx="11091672" cy="603504"/>
+            <a:off x="8983980" y="1463040"/>
+            <a:ext cx="2656332" cy="4160520"/>
           </a:xfrm>
           <a:prstGeom prst="rect">
             <a:avLst/>
@@ -13557,8 +13557,8 @@
         </p:nvSpPr>
         <p:spPr>
           <a:xfrm>
-            <a:off x="548640" y="5760720"/>
-            <a:ext cx="64008" cy="603504"/>
+            <a:off x="8983980" y="1463040"/>
+            <a:ext cx="2656332" cy="45720"/>
           </a:xfrm>
           <a:prstGeom prst="rect">
             <a:avLst/>
@@ -13601,6 +13601,159 @@
         </p:nvSpPr>
         <p:spPr>
           <a:xfrm>
+            <a:off x="9240012" y="1664208"/>
+            <a:ext cx="2144268" cy="3886200"/>
+          </a:xfrm>
+          <a:prstGeom prst="rect">
+            <a:avLst/>
+          </a:prstGeom>
+          <a:noFill/>
+        </p:spPr>
+        <p:txBody>
+          <a:bodyPr wrap="square" anchor="t" lIns="0" rIns="0" tIns="0" bIns="0">
+            <a:spAutoFit/>
+          </a:bodyPr>
+          <a:lstStyle/>
+          <a:p>
+            <a:pPr algn="l"/>
+            <a:r>
+              <a:rPr sz="1000" b="1">
+                <a:solidFill>
+                  <a:srgbClr val="C9A227"/>
+                </a:solidFill>
+              </a:rPr>
+              <a:t>STEP 4</a:t>
+            </a:r>
+          </a:p>
+          <a:p>
+            <a:pPr algn="l">
+              <a:spcBef>
+                <a:spcPts val="400"/>
+              </a:spcBef>
+            </a:pPr>
+            <a:r>
+              <a:rPr sz="1600" b="1">
+                <a:solidFill>
+                  <a:srgbClr val="FFFFFF"/>
+                </a:solidFill>
+                <a:latin typeface="Georgia"/>
+              </a:rPr>
+              <a:t>Paste the prompt</a:t>
+            </a:r>
+          </a:p>
+          <a:p>
+            <a:pPr algn="l">
+              <a:spcBef>
+                <a:spcPts val="600"/>
+              </a:spcBef>
+            </a:pPr>
+            <a:r>
+              <a:rPr sz="1200" b="0">
+                <a:solidFill>
+                  <a:srgbClr val="C9D6EE"/>
+                </a:solidFill>
+              </a:rPr>
+              <a:t>Claude writes the page, the script and the 6:30 AM routine. Merge, then run it once.</a:t>
+            </a:r>
+          </a:p>
+        </p:txBody>
+      </p:sp>
+      <p:sp>
+        <p:nvSpPr>
+          <p:cNvPr id="17" name="Rectangle 16"/>
+          <p:cNvSpPr/>
+          <p:nvPr/>
+        </p:nvSpPr>
+        <p:spPr>
+          <a:xfrm>
+            <a:off x="548640" y="5760720"/>
+            <a:ext cx="11091672" cy="603504"/>
+          </a:xfrm>
+          <a:prstGeom prst="rect">
+            <a:avLst/>
+          </a:prstGeom>
+          <a:solidFill>
+            <a:srgbClr val="0F2145"/>
+          </a:solidFill>
+          <a:ln>
+            <a:noFill/>
+          </a:ln>
+          <a:effectLst/>
+        </p:spPr>
+        <p:style>
+          <a:lnRef idx="1">
+            <a:schemeClr val="accent1"/>
+          </a:lnRef>
+          <a:fillRef idx="3">
+            <a:schemeClr val="accent1"/>
+          </a:fillRef>
+          <a:effectRef idx="2">
+            <a:schemeClr val="accent1"/>
+          </a:effectRef>
+          <a:fontRef idx="minor">
+            <a:schemeClr val="lt1"/>
+          </a:fontRef>
+        </p:style>
+        <p:txBody>
+          <a:bodyPr rtlCol="0" anchor="ctr"/>
+          <a:lstStyle/>
+          <a:p>
+            <a:pPr algn="ctr"/>
+          </a:p>
+        </p:txBody>
+      </p:sp>
+      <p:sp>
+        <p:nvSpPr>
+          <p:cNvPr id="18" name="Rectangle 17"/>
+          <p:cNvSpPr/>
+          <p:nvPr/>
+        </p:nvSpPr>
+        <p:spPr>
+          <a:xfrm>
+            <a:off x="548640" y="5760720"/>
+            <a:ext cx="64008" cy="603504"/>
+          </a:xfrm>
+          <a:prstGeom prst="rect">
+            <a:avLst/>
+          </a:prstGeom>
+          <a:solidFill>
+            <a:srgbClr val="C9A227"/>
+          </a:solidFill>
+          <a:ln>
+            <a:noFill/>
+          </a:ln>
+          <a:effectLst/>
+        </p:spPr>
+        <p:style>
+          <a:lnRef idx="1">
+            <a:schemeClr val="accent1"/>
+          </a:lnRef>
+          <a:fillRef idx="3">
+            <a:schemeClr val="accent1"/>
+          </a:fillRef>
+          <a:effectRef idx="2">
+            <a:schemeClr val="accent1"/>
+          </a:effectRef>
+          <a:fontRef idx="minor">
+            <a:schemeClr val="lt1"/>
+          </a:fontRef>
+        </p:style>
+        <p:txBody>
+          <a:bodyPr rtlCol="0" anchor="ctr"/>
+          <a:lstStyle/>
+          <a:p>
+            <a:pPr algn="ctr"/>
+          </a:p>
+        </p:txBody>
+      </p:sp>
+      <p:sp>
+        <p:nvSpPr>
+          <p:cNvPr id="19" name="TextBox 18"/>
+          <p:cNvSpPr txBox="1"/>
+          <p:nvPr/>
+        </p:nvSpPr>
+        <p:spPr>
+          <a:xfrm>
             <a:off x="822960" y="5760720"/>
             <a:ext cx="10543032" cy="603504"/>
           </a:xfrm>
@@ -13622,7 +13775,7 @@
                   <a:srgbClr val="C9A227"/>
                 </a:solidFill>
               </a:rPr>
-              <a:t>No API key?  </a:t>
+              <a:t>Two bills:  </a:t>
             </a:r>
             <a:r>
               <a:rPr sz="1200" b="0">
@@ -13630,14 +13783,14 @@
                   <a:srgbClr val="FFFFFF"/>
                 </a:solidFill>
               </a:rPr>
-              <a:t>the lab page also has a free practice version in plain Python, with a DCF and a refusal on missing data.</a:t>
-            </a:r>
-          </a:p>
-        </p:txBody>
-      </p:sp>
-      <p:sp>
-        <p:nvSpPr>
-          <p:cNvPr id="17" name="TextBox 16"/>
+              <a:t>a Claude plan lets Claude write the files, and the API key pays for each morning update.</a:t>
+            </a:r>
+          </a:p>
+        </p:txBody>
+      </p:sp>
+      <p:sp>
+        <p:nvSpPr>
+          <p:cNvPr id="20" name="TextBox 19"/>
           <p:cNvSpPr txBox="1"/>
           <p:nvPr/>
         </p:nvSpPr>
@@ -13671,7 +13824,7 @@
       </p:sp>
       <p:sp>
         <p:nvSpPr>
-          <p:cNvPr id="18" name="TextBox 17"/>
+          <p:cNvPr id="21" name="TextBox 20"/>
           <p:cNvSpPr txBox="1"/>
           <p:nvPr/>
         </p:nvSpPr>

</xml_diff>

<commit_message>
Module 9 deck: slide 7 matches the routine and files the prompt builds; slide 8 tightened
Co-Authored-By: Claude Opus 5.5 <noreply@anthropic.com>
</commit_message>
<xml_diff>
--- a/slides/Module-09-Market-Commentary-and-Dashboards.pptx
+++ b/slides/Module-09-Market-Commentary-and-Dashboards.pptx
@@ -11492,7 +11492,7 @@
                 </a:solidFill>
                 <a:latin typeface="Georgia"/>
               </a:rPr>
-              <a:t>Five steps, run by a schedule</a:t>
+              <a:t>What runs every weekday at 6:30 AM</a:t>
             </a:r>
           </a:p>
         </p:txBody>
@@ -11631,7 +11631,7 @@
                 </a:solidFill>
                 <a:latin typeface="Georgia"/>
               </a:rPr>
-              <a:t>Schedule</a:t>
+              <a:t>Routine</a:t>
             </a:r>
           </a:p>
           <a:p>
@@ -11646,7 +11646,7 @@
                   <a:srgbClr val="1B2A41"/>
                 </a:solidFill>
               </a:rPr>
-              <a:t>GitHub Actions starts the job every weekday morning.</a:t>
+              <a:t>daily-update.yml starts the job at 6:30 AM IST, Monday to Friday.</a:t>
             </a:r>
           </a:p>
         </p:txBody>
@@ -11834,7 +11834,7 @@
                   <a:srgbClr val="1B2A41"/>
                 </a:solidFill>
               </a:rPr>
-              <a:t>Sends Claude a fixed prompt template and today's page.</a:t>
+              <a:t>update_dashboard.py takes the API key from the GitHub secret and sends the prompt template and today's page.</a:t>
             </a:r>
           </a:p>
         </p:txBody>
@@ -12022,7 +12022,7 @@
                   <a:srgbClr val="C9D6EE"/>
                 </a:solidFill>
               </a:rPr>
-              <a:t>Runs ten or more web searches and writes the updated page.</a:t>
+              <a:t>Runs ten or more web searches, gives a source for each number, and writes “not found” rather than guess.</a:t>
             </a:r>
           </a:p>
         </p:txBody>
@@ -12210,7 +12210,7 @@
                   <a:srgbClr val="1B2A41"/>
                 </a:solidFill>
               </a:rPr>
-              <a:t>The script checks the new page is complete before saving it.</a:t>
+              <a:t>If the new page is incomplete or the disclaimer is missing, yesterday's page stays.</a:t>
             </a:r>
           </a:p>
         </p:txBody>
@@ -12398,7 +12398,7 @@
                   <a:srgbClr val="1B2A41"/>
                 </a:solidFill>
               </a:rPr>
-              <a:t>The page is saved to GitHub and goes live on GitHub Pages.</a:t>
+              <a:t>index.html is committed to GitHub and goes live on GitHub Pages.</a:t>
             </a:r>
           </a:p>
         </p:txBody>
@@ -12551,7 +12551,7 @@
                   <a:srgbClr val="1B2A41"/>
                 </a:solidFill>
               </a:rPr>
-              <a:t>A schedule, a fixed prompt, a safety check and free hosting.</a:t>
+              <a:t>One prompt built it. A routine, a fixed template, a safety check and free hosting run it.</a:t>
             </a:r>
           </a:p>
         </p:txBody>
@@ -13055,7 +13055,7 @@
         <p:spPr>
           <a:xfrm>
             <a:off x="548640" y="1463040"/>
-            <a:ext cx="2656332" cy="4160520"/>
+            <a:ext cx="2656332" cy="2194560"/>
           </a:xfrm>
           <a:prstGeom prst="rect">
             <a:avLst/>
@@ -13143,7 +13143,7 @@
         <p:spPr>
           <a:xfrm>
             <a:off x="804672" y="1664208"/>
-            <a:ext cx="2144268" cy="3886200"/>
+            <a:ext cx="2144268" cy="1920240"/>
           </a:xfrm>
           <a:prstGeom prst="rect">
             <a:avLst/>
@@ -13208,7 +13208,7 @@
         <p:spPr>
           <a:xfrm>
             <a:off x="3360420" y="1463040"/>
-            <a:ext cx="2656332" cy="4160520"/>
+            <a:ext cx="2656332" cy="2194560"/>
           </a:xfrm>
           <a:prstGeom prst="rect">
             <a:avLst/>
@@ -13296,7 +13296,7 @@
         <p:spPr>
           <a:xfrm>
             <a:off x="3616452" y="1664208"/>
-            <a:ext cx="2144268" cy="3886200"/>
+            <a:ext cx="2144268" cy="1920240"/>
           </a:xfrm>
           <a:prstGeom prst="rect">
             <a:avLst/>
@@ -13361,7 +13361,7 @@
         <p:spPr>
           <a:xfrm>
             <a:off x="6172200" y="1463040"/>
-            <a:ext cx="2656332" cy="4160520"/>
+            <a:ext cx="2656332" cy="2194560"/>
           </a:xfrm>
           <a:prstGeom prst="rect">
             <a:avLst/>
@@ -13449,7 +13449,7 @@
         <p:spPr>
           <a:xfrm>
             <a:off x="6428232" y="1664208"/>
-            <a:ext cx="2144268" cy="3886200"/>
+            <a:ext cx="2144268" cy="1920240"/>
           </a:xfrm>
           <a:prstGeom prst="rect">
             <a:avLst/>
@@ -13514,7 +13514,7 @@
         <p:spPr>
           <a:xfrm>
             <a:off x="8983980" y="1463040"/>
-            <a:ext cx="2656332" cy="4160520"/>
+            <a:ext cx="2656332" cy="2194560"/>
           </a:xfrm>
           <a:prstGeom prst="rect">
             <a:avLst/>
@@ -13602,7 +13602,7 @@
         <p:spPr>
           <a:xfrm>
             <a:off x="9240012" y="1664208"/>
-            <a:ext cx="2144268" cy="3886200"/>
+            <a:ext cx="2144268" cy="1920240"/>
           </a:xfrm>
           <a:prstGeom prst="rect">
             <a:avLst/>

</xml_diff>